<commit_message>
Mainly last minute prep for SqlDay Lite
</commit_message>
<xml_diff>
--- a/sql-server-worst-practices/sql-server-worst-practices.pptx
+++ b/sql-server-worst-practices/sql-server-worst-practices.pptx
@@ -214,7 +214,7 @@
           <a:p>
             <a:fld id="{36B85829-DE77-4927-8834-2B86EE4EE4A6}" type="datetimeFigureOut">
               <a:rPr lang="LID4096" smtClean="0"/>
-              <a:t>10/28/2024</a:t>
+              <a:t>10/16/2025</a:t>
             </a:fld>
             <a:endParaRPr lang="LID4096"/>
           </a:p>
@@ -899,7 +899,7 @@
           <a:p>
             <a:fld id="{2669C624-DE7C-4C92-B706-E4A2487C993D}" type="datetimeFigureOut">
               <a:rPr lang="LID4096" smtClean="0"/>
-              <a:t>10/28/2024</a:t>
+              <a:t>10/16/2025</a:t>
             </a:fld>
             <a:endParaRPr lang="LID4096"/>
           </a:p>
@@ -1099,7 +1099,7 @@
           <a:p>
             <a:fld id="{2669C624-DE7C-4C92-B706-E4A2487C993D}" type="datetimeFigureOut">
               <a:rPr lang="LID4096" smtClean="0"/>
-              <a:t>10/28/2024</a:t>
+              <a:t>10/16/2025</a:t>
             </a:fld>
             <a:endParaRPr lang="LID4096"/>
           </a:p>
@@ -1309,7 +1309,7 @@
           <a:p>
             <a:fld id="{2669C624-DE7C-4C92-B706-E4A2487C993D}" type="datetimeFigureOut">
               <a:rPr lang="LID4096" smtClean="0"/>
-              <a:t>10/28/2024</a:t>
+              <a:t>10/16/2025</a:t>
             </a:fld>
             <a:endParaRPr lang="LID4096"/>
           </a:p>
@@ -1509,7 +1509,7 @@
           <a:p>
             <a:fld id="{2669C624-DE7C-4C92-B706-E4A2487C993D}" type="datetimeFigureOut">
               <a:rPr lang="LID4096" smtClean="0"/>
-              <a:t>10/28/2024</a:t>
+              <a:t>10/16/2025</a:t>
             </a:fld>
             <a:endParaRPr lang="LID4096"/>
           </a:p>
@@ -1785,7 +1785,7 @@
           <a:p>
             <a:fld id="{2669C624-DE7C-4C92-B706-E4A2487C993D}" type="datetimeFigureOut">
               <a:rPr lang="LID4096" smtClean="0"/>
-              <a:t>10/28/2024</a:t>
+              <a:t>10/16/2025</a:t>
             </a:fld>
             <a:endParaRPr lang="LID4096"/>
           </a:p>
@@ -2053,7 +2053,7 @@
           <a:p>
             <a:fld id="{2669C624-DE7C-4C92-B706-E4A2487C993D}" type="datetimeFigureOut">
               <a:rPr lang="LID4096" smtClean="0"/>
-              <a:t>10/28/2024</a:t>
+              <a:t>10/16/2025</a:t>
             </a:fld>
             <a:endParaRPr lang="LID4096"/>
           </a:p>
@@ -2468,7 +2468,7 @@
           <a:p>
             <a:fld id="{2669C624-DE7C-4C92-B706-E4A2487C993D}" type="datetimeFigureOut">
               <a:rPr lang="LID4096" smtClean="0"/>
-              <a:t>10/28/2024</a:t>
+              <a:t>10/16/2025</a:t>
             </a:fld>
             <a:endParaRPr lang="LID4096"/>
           </a:p>
@@ -2610,7 +2610,7 @@
           <a:p>
             <a:fld id="{2669C624-DE7C-4C92-B706-E4A2487C993D}" type="datetimeFigureOut">
               <a:rPr lang="LID4096" smtClean="0"/>
-              <a:t>10/28/2024</a:t>
+              <a:t>10/16/2025</a:t>
             </a:fld>
             <a:endParaRPr lang="LID4096"/>
           </a:p>
@@ -2723,7 +2723,7 @@
           <a:p>
             <a:fld id="{2669C624-DE7C-4C92-B706-E4A2487C993D}" type="datetimeFigureOut">
               <a:rPr lang="LID4096" smtClean="0"/>
-              <a:t>10/28/2024</a:t>
+              <a:t>10/16/2025</a:t>
             </a:fld>
             <a:endParaRPr lang="LID4096"/>
           </a:p>
@@ -3036,7 +3036,7 @@
           <a:p>
             <a:fld id="{2669C624-DE7C-4C92-B706-E4A2487C993D}" type="datetimeFigureOut">
               <a:rPr lang="LID4096" smtClean="0"/>
-              <a:t>10/28/2024</a:t>
+              <a:t>10/16/2025</a:t>
             </a:fld>
             <a:endParaRPr lang="LID4096"/>
           </a:p>
@@ -3325,7 +3325,7 @@
           <a:p>
             <a:fld id="{2669C624-DE7C-4C92-B706-E4A2487C993D}" type="datetimeFigureOut">
               <a:rPr lang="LID4096" smtClean="0"/>
-              <a:t>10/28/2024</a:t>
+              <a:t>10/16/2025</a:t>
             </a:fld>
             <a:endParaRPr lang="LID4096"/>
           </a:p>
@@ -3568,7 +3568,7 @@
           <a:p>
             <a:fld id="{2669C624-DE7C-4C92-B706-E4A2487C993D}" type="datetimeFigureOut">
               <a:rPr lang="LID4096" smtClean="0"/>
-              <a:t>10/28/2024</a:t>
+              <a:t>10/16/2025</a:t>
             </a:fld>
             <a:endParaRPr lang="LID4096"/>
           </a:p>
@@ -5985,7 +5985,7 @@
         </p:spPr>
         <p:txBody>
           <a:bodyPr>
-            <a:normAutofit fontScale="70000" lnSpcReduction="20000"/>
+            <a:normAutofit fontScale="77500" lnSpcReduction="20000"/>
           </a:bodyPr>
           <a:lstStyle/>
           <a:p>
@@ -6030,21 +6030,14 @@
             <a:pPr lvl="1"/>
             <a:r>
               <a:rPr lang="en-GB" sz="1800" dirty="0"/>
-              <a:t>Yes, I know.</a:t>
+              <a:t>Uh, yeah? What about it?</a:t>
             </a:r>
           </a:p>
           <a:p>
             <a:pPr lvl="1"/>
             <a:r>
               <a:rPr lang="en-GB" sz="1800" dirty="0"/>
-              <a:t>Uh, yeah? What about it?</a:t>
-            </a:r>
-          </a:p>
-          <a:p>
-            <a:pPr lvl="1"/>
-            <a:r>
-              <a:rPr lang="en-GB" sz="1800" dirty="0"/>
-              <a:t>Yep, so you probably need to make sure we have more disk to allocate from our SAN.</a:t>
+              <a:t>Yes, so you probably need to make sure we have more disk to allocate from our SAN.</a:t>
             </a:r>
             <a:endParaRPr lang="LID4096" sz="1800" dirty="0"/>
           </a:p>
@@ -6634,55 +6627,6 @@
                                           <p:spTgt spid="3">
                                             <p:txEl>
                                               <p:pRg st="6" end="6"/>
-                                            </p:txEl>
-                                          </p:spTgt>
-                                        </p:tgtEl>
-                                        <p:attrNameLst>
-                                          <p:attrName>style.visibility</p:attrName>
-                                        </p:attrNameLst>
-                                      </p:cBhvr>
-                                      <p:to>
-                                        <p:strVal val="visible"/>
-                                      </p:to>
-                                    </p:set>
-                                  </p:childTnLst>
-                                </p:cTn>
-                              </p:par>
-                            </p:childTnLst>
-                          </p:cTn>
-                        </p:par>
-                      </p:childTnLst>
-                    </p:cTn>
-                  </p:par>
-                  <p:par>
-                    <p:cTn id="31" fill="hold">
-                      <p:stCondLst>
-                        <p:cond delay="indefinite"/>
-                      </p:stCondLst>
-                      <p:childTnLst>
-                        <p:par>
-                          <p:cTn id="32" fill="hold">
-                            <p:stCondLst>
-                              <p:cond delay="0"/>
-                            </p:stCondLst>
-                            <p:childTnLst>
-                              <p:par>
-                                <p:cTn id="33" presetID="1" presetClass="entr" presetSubtype="0" fill="hold" grpId="0" nodeType="clickEffect">
-                                  <p:stCondLst>
-                                    <p:cond delay="0"/>
-                                  </p:stCondLst>
-                                  <p:childTnLst>
-                                    <p:set>
-                                      <p:cBhvr>
-                                        <p:cTn id="34" dur="1" fill="hold">
-                                          <p:stCondLst>
-                                            <p:cond delay="0"/>
-                                          </p:stCondLst>
-                                        </p:cTn>
-                                        <p:tgtEl>
-                                          <p:spTgt spid="3">
-                                            <p:txEl>
-                                              <p:pRg st="7" end="7"/>
                                             </p:txEl>
                                           </p:spTgt>
                                         </p:tgtEl>
@@ -19518,7 +19462,7 @@
                   <a:schemeClr val="bg1"/>
                 </a:solidFill>
               </a:rPr>
-              <a:t>I heard the word “RBAR” and that’s exactly what I want to do – mastering every row in the database!</a:t>
+              <a:t>I heard the word “RBAR” and that’s exactly what I want to do – master every row in the database!</a:t>
             </a:r>
           </a:p>
         </p:txBody>
@@ -23040,7 +22984,7 @@
         </p:spPr>
         <p:txBody>
           <a:bodyPr>
-            <a:normAutofit/>
+            <a:normAutofit fontScale="92500" lnSpcReduction="20000"/>
           </a:bodyPr>
           <a:lstStyle/>
           <a:p>
@@ -23287,7 +23231,13 @@
             </a:r>
             <a:r>
               <a:rPr lang="sv-SE" sz="1700" dirty="0"/>
-              <a:t> UGLY. And it </a:t>
+              <a:t> UGLY. </a:t>
+            </a:r>
+          </a:p>
+          <a:p>
+            <a:r>
+              <a:rPr lang="sv-SE" sz="1700" dirty="0"/>
+              <a:t>And it </a:t>
             </a:r>
             <a:r>
               <a:rPr lang="sv-SE" sz="1700" dirty="0" err="1"/>
@@ -23313,6 +23263,16 @@
               <a:rPr lang="sv-SE" sz="1700" dirty="0"/>
               <a:t>.</a:t>
             </a:r>
+          </a:p>
+          <a:p>
+            <a:endParaRPr lang="sv-SE" sz="1700" dirty="0"/>
+          </a:p>
+          <a:p>
+            <a:r>
+              <a:rPr lang="sv-SE" sz="1700"/>
+              <a:t>DEMO!!</a:t>
+            </a:r>
+            <a:endParaRPr lang="sv-SE" sz="1700" dirty="0"/>
           </a:p>
         </p:txBody>
       </p:sp>
@@ -23687,18 +23647,196 @@
                             </p:stCondLst>
                             <p:childTnLst>
                               <p:par>
-                                <p:cTn id="29" presetID="6" presetClass="emph" presetSubtype="0" fill="hold" nodeType="clickEffect">
+                                <p:cTn id="29" presetID="1" presetClass="entr" presetSubtype="0" fill="hold" grpId="0" nodeType="clickEffect">
+                                  <p:stCondLst>
+                                    <p:cond delay="0"/>
+                                  </p:stCondLst>
+                                  <p:childTnLst>
+                                    <p:set>
+                                      <p:cBhvr>
+                                        <p:cTn id="30" dur="1" fill="hold">
+                                          <p:stCondLst>
+                                            <p:cond delay="0"/>
+                                          </p:stCondLst>
+                                        </p:cTn>
+                                        <p:tgtEl>
+                                          <p:spTgt spid="3">
+                                            <p:txEl>
+                                              <p:pRg st="6" end="6"/>
+                                            </p:txEl>
+                                          </p:spTgt>
+                                        </p:tgtEl>
+                                        <p:attrNameLst>
+                                          <p:attrName>style.visibility</p:attrName>
+                                        </p:attrNameLst>
+                                      </p:cBhvr>
+                                      <p:to>
+                                        <p:strVal val="visible"/>
+                                      </p:to>
+                                    </p:set>
+                                  </p:childTnLst>
+                                </p:cTn>
+                              </p:par>
+                            </p:childTnLst>
+                          </p:cTn>
+                        </p:par>
+                      </p:childTnLst>
+                    </p:cTn>
+                  </p:par>
+                  <p:par>
+                    <p:cTn id="31" fill="hold">
+                      <p:stCondLst>
+                        <p:cond delay="indefinite"/>
+                      </p:stCondLst>
+                      <p:childTnLst>
+                        <p:par>
+                          <p:cTn id="32" fill="hold">
+                            <p:stCondLst>
+                              <p:cond delay="0"/>
+                            </p:stCondLst>
+                            <p:childTnLst>
+                              <p:par>
+                                <p:cTn id="33" presetID="1" presetClass="entr" presetSubtype="0" fill="hold" grpId="0" nodeType="clickEffect">
+                                  <p:stCondLst>
+                                    <p:cond delay="0"/>
+                                  </p:stCondLst>
+                                  <p:childTnLst>
+                                    <p:set>
+                                      <p:cBhvr>
+                                        <p:cTn id="34" dur="1" fill="hold">
+                                          <p:stCondLst>
+                                            <p:cond delay="0"/>
+                                          </p:stCondLst>
+                                        </p:cTn>
+                                        <p:tgtEl>
+                                          <p:spTgt spid="3">
+                                            <p:txEl>
+                                              <p:pRg st="8" end="8"/>
+                                            </p:txEl>
+                                          </p:spTgt>
+                                        </p:tgtEl>
+                                        <p:attrNameLst>
+                                          <p:attrName>style.visibility</p:attrName>
+                                        </p:attrNameLst>
+                                      </p:cBhvr>
+                                      <p:to>
+                                        <p:strVal val="visible"/>
+                                      </p:to>
+                                    </p:set>
+                                  </p:childTnLst>
+                                </p:cTn>
+                              </p:par>
+                            </p:childTnLst>
+                          </p:cTn>
+                        </p:par>
+                      </p:childTnLst>
+                    </p:cTn>
+                  </p:par>
+                  <p:par>
+                    <p:cTn id="35" fill="hold">
+                      <p:stCondLst>
+                        <p:cond delay="indefinite"/>
+                      </p:stCondLst>
+                      <p:childTnLst>
+                        <p:par>
+                          <p:cTn id="36" fill="hold">
+                            <p:stCondLst>
+                              <p:cond delay="0"/>
+                            </p:stCondLst>
+                            <p:childTnLst>
+                              <p:par>
+                                <p:cTn id="37" presetID="6" presetClass="emph" presetSubtype="0" fill="hold" nodeType="clickEffect">
                                   <p:stCondLst>
                                     <p:cond delay="0"/>
                                   </p:stCondLst>
                                   <p:childTnLst>
                                     <p:animScale>
                                       <p:cBhvr>
-                                        <p:cTn id="30" dur="2000" fill="hold"/>
+                                        <p:cTn id="38" dur="2000" fill="hold"/>
                                         <p:tgtEl>
                                           <p:spTgt spid="3">
                                             <p:txEl>
                                               <p:pRg st="5" end="5"/>
+                                            </p:txEl>
+                                          </p:spTgt>
+                                        </p:tgtEl>
+                                      </p:cBhvr>
+                                      <p:by x="150000" y="150000"/>
+                                    </p:animScale>
+                                  </p:childTnLst>
+                                </p:cTn>
+                              </p:par>
+                            </p:childTnLst>
+                          </p:cTn>
+                        </p:par>
+                      </p:childTnLst>
+                    </p:cTn>
+                  </p:par>
+                  <p:par>
+                    <p:cTn id="39" fill="hold">
+                      <p:stCondLst>
+                        <p:cond delay="indefinite"/>
+                      </p:stCondLst>
+                      <p:childTnLst>
+                        <p:par>
+                          <p:cTn id="40" fill="hold">
+                            <p:stCondLst>
+                              <p:cond delay="0"/>
+                            </p:stCondLst>
+                            <p:childTnLst>
+                              <p:par>
+                                <p:cTn id="41" presetID="6" presetClass="emph" presetSubtype="0" fill="hold" nodeType="clickEffect">
+                                  <p:stCondLst>
+                                    <p:cond delay="0"/>
+                                  </p:stCondLst>
+                                  <p:childTnLst>
+                                    <p:animScale>
+                                      <p:cBhvr>
+                                        <p:cTn id="42" dur="2000" fill="hold"/>
+                                        <p:tgtEl>
+                                          <p:spTgt spid="3">
+                                            <p:txEl>
+                                              <p:pRg st="6" end="6"/>
+                                            </p:txEl>
+                                          </p:spTgt>
+                                        </p:tgtEl>
+                                      </p:cBhvr>
+                                      <p:by x="150000" y="150000"/>
+                                    </p:animScale>
+                                  </p:childTnLst>
+                                </p:cTn>
+                              </p:par>
+                            </p:childTnLst>
+                          </p:cTn>
+                        </p:par>
+                      </p:childTnLst>
+                    </p:cTn>
+                  </p:par>
+                  <p:par>
+                    <p:cTn id="43" fill="hold">
+                      <p:stCondLst>
+                        <p:cond delay="indefinite"/>
+                      </p:stCondLst>
+                      <p:childTnLst>
+                        <p:par>
+                          <p:cTn id="44" fill="hold">
+                            <p:stCondLst>
+                              <p:cond delay="0"/>
+                            </p:stCondLst>
+                            <p:childTnLst>
+                              <p:par>
+                                <p:cTn id="45" presetID="6" presetClass="emph" presetSubtype="0" fill="hold" nodeType="clickEffect">
+                                  <p:stCondLst>
+                                    <p:cond delay="0"/>
+                                  </p:stCondLst>
+                                  <p:childTnLst>
+                                    <p:animScale>
+                                      <p:cBhvr>
+                                        <p:cTn id="46" dur="2000" fill="hold"/>
+                                        <p:tgtEl>
+                                          <p:spTgt spid="3">
+                                            <p:txEl>
+                                              <p:pRg st="8" end="8"/>
                                             </p:txEl>
                                           </p:spTgt>
                                         </p:tgtEl>
@@ -23856,10 +23994,10 @@
           <a:lstStyle/>
           <a:p>
             <a:r>
-              <a:rPr lang="en-GB" sz="4800"/>
-              <a:t>Readable code, it’s a real thing</a:t>
-            </a:r>
-            <a:endParaRPr lang="LID4096" sz="4800"/>
+              <a:rPr lang="en-GB" sz="4800" dirty="0"/>
+              <a:t>Unreadable code</a:t>
+            </a:r>
+            <a:endParaRPr lang="LID4096" sz="4800" dirty="0"/>
           </a:p>
         </p:txBody>
       </p:sp>
@@ -24402,7 +24540,7 @@
         </p:spPr>
         <p:txBody>
           <a:bodyPr anchor="t">
-            <a:normAutofit/>
+            <a:normAutofit lnSpcReduction="10000"/>
           </a:bodyPr>
           <a:lstStyle/>
           <a:p>
@@ -24414,7 +24552,7 @@
                   </a:schemeClr>
                 </a:solidFill>
               </a:rPr>
-              <a:t>No nested IF’s and ELSE’s please.</a:t>
+              <a:t>Nested IF’s and ELSE</a:t>
             </a:r>
           </a:p>
           <a:p>
@@ -24426,7 +24564,7 @@
                   </a:schemeClr>
                 </a:solidFill>
               </a:rPr>
-              <a:t>Remove code that isn’t used. Don’t comment it out.</a:t>
+              <a:t>Code that is no longer in use: Comment it out, so that the stored procedures are all 1.000 lines of comments and 50 lines of actual code.</a:t>
             </a:r>
           </a:p>
           <a:p>
@@ -24438,7 +24576,7 @@
                   </a:schemeClr>
                 </a:solidFill>
               </a:rPr>
-              <a:t>Local variables and procedure/function parameters – please don’t name them @P1 or @myLocalVariable</a:t>
+              <a:t>It takes time to come up with good names for local variables and temporary objects: Use @p1, @myLocalVariable and #tmp</a:t>
             </a:r>
             <a:endParaRPr lang="LID4096" sz="2000" dirty="0">
               <a:solidFill>

</xml_diff>